<commit_message>
Updated for Houston Fabric Day
</commit_message>
<xml_diff>
--- a/Microsoft Fabric/Demystifying Microsoft Fabric/20260613 - Houston Fabric Day - Demystifying Microsoft Fabric.pptx
+++ b/Microsoft Fabric/Demystifying Microsoft Fabric/20260613 - Houston Fabric Day - Demystifying Microsoft Fabric.pptx
@@ -11736,42 +11736,18 @@
             <a:pPr algn="l"/>
             <a:r>
               <a:rPr lang="en-US" sz="2400" dirty="0"/>
-              <a:t>Structured data, </a:t>
-            </a:r>
-            <a:r>
-              <a:rPr lang="en-US" sz="2400" dirty="0" err="1"/>
-              <a:t>ie</a:t>
-            </a:r>
+              <a:t>Structured data, e.g. .csv, .xlsx files​ and semi-structured data, e.g. JSON, XML​</a:t>
+            </a:r>
+          </a:p>
+          <a:p>
+            <a:pPr algn="l"/>
+            <a:endParaRPr lang="en-US" sz="1200" dirty="0"/>
+          </a:p>
+          <a:p>
+            <a:pPr algn="l"/>
             <a:r>
               <a:rPr lang="en-US" sz="2400" dirty="0"/>
-              <a:t>. tables, .csv files​ and semi-structured data, </a:t>
-            </a:r>
-            <a:r>
-              <a:rPr lang="en-US" sz="2400" dirty="0" err="1"/>
-              <a:t>ie</a:t>
-            </a:r>
-            <a:r>
-              <a:rPr lang="en-US" sz="2400" dirty="0"/>
-              <a:t>. JSON, XML​</a:t>
-            </a:r>
-          </a:p>
-          <a:p>
-            <a:pPr algn="l"/>
-            <a:endParaRPr lang="en-US" sz="1200" dirty="0"/>
-          </a:p>
-          <a:p>
-            <a:pPr algn="l"/>
-            <a:r>
-              <a:rPr lang="en-US" sz="2400" dirty="0"/>
-              <a:t>Unstructured data, </a:t>
-            </a:r>
-            <a:r>
-              <a:rPr lang="en-US" sz="2400" dirty="0" err="1"/>
-              <a:t>ie</a:t>
-            </a:r>
-            <a:r>
-              <a:rPr lang="en-US" sz="2400" dirty="0"/>
-              <a:t>. images, sound files, video files​</a:t>
+              <a:t>Unstructured data, e.g. images, sound files, video files​</a:t>
             </a:r>
           </a:p>
           <a:p>

</xml_diff>